<commit_message>
Integrate input-state identifiability as an ACCESS-stage refinement
Refine ACCESS into resource accessibility / input-state identifiability /
historical-state retrievability without adding a top-level stage. Adds Methods
2.1a, Discussion 7.1, a proposed minimum reporting set, Tables 10-11
(requirement-to-stage mapping; descriptive fields as recorded), Figure 1
annotation, public retrieval ledger of the 21 served inputs, 11 verified
references with a citation verification table, README/note documentation and
nine QC checks. No gate, barrier state, sealed outcome, A/B/C/E record or
Section D status is changed.

Co-Authored-By: Tatsuki Onishi <bougtoir@gmail.com>
</commit_message>
<xml_diff>
--- a/paper2_reconstruction/manuscript/Figures_editable_EN.pptx
+++ b/paper2_reconstruction/manuscript/Figures_editable_EN.pptx
@@ -3542,8 +3542,8 @@
         </p:nvSpPr>
         <p:spPr>
           <a:xfrm>
-            <a:off x="2743200" y="1719072"/>
-            <a:ext cx="6858000" cy="411480"/>
+            <a:off x="274320" y="1664208"/>
+            <a:ext cx="2194560" cy="822960"/>
           </a:xfrm>
           <a:prstGeom prst="rect">
             <a:avLst/>
@@ -3557,14 +3557,38 @@
           <a:lstStyle/>
           <a:p>
             <a:pPr>
-              <a:defRPr sz="1500">
+              <a:defRPr sz="900">
                 <a:solidFill>
                   <a:srgbClr val="0F172A"/>
                 </a:solidFill>
               </a:defRPr>
             </a:pPr>
             <a:r>
-              <a:t>Paper II focus and downstream observations</a:t>
+              <a:t>├ resource accessible?</a:t>
+            </a:r>
+          </a:p>
+          <a:p>
+            <a:pPr>
+              <a:defRPr sz="900">
+                <a:solidFill>
+                  <a:srgbClr val="0F172A"/>
+                </a:solidFill>
+              </a:defRPr>
+            </a:pPr>
+            <a:r>
+              <a:t>├ exact input state identifiable?</a:t>
+            </a:r>
+          </a:p>
+          <a:p>
+            <a:pPr>
+              <a:defRPr sz="900">
+                <a:solidFill>
+                  <a:srgbClr val="0F172A"/>
+                </a:solidFill>
+              </a:defRPr>
+            </a:pPr>
+            <a:r>
+              <a:t>├ historical input state retrievable?</a:t>
             </a:r>
           </a:p>
         </p:txBody>
@@ -3577,8 +3601,8 @@
         </p:nvSpPr>
         <p:spPr>
           <a:xfrm>
-            <a:off x="9784080" y="1719072"/>
-            <a:ext cx="2103120" cy="457200"/>
+            <a:off x="2743200" y="1664208"/>
+            <a:ext cx="6858000" cy="365760"/>
           </a:xfrm>
           <a:prstGeom prst="rect">
             <a:avLst/>
@@ -3592,14 +3616,14 @@
           <a:lstStyle/>
           <a:p>
             <a:pPr>
-              <a:defRPr sz="1400">
+              <a:defRPr sz="1500">
                 <a:solidFill>
                   <a:srgbClr val="0F172A"/>
                 </a:solidFill>
               </a:defRPr>
             </a:pPr>
             <a:r>
-              <a:t>Paper III: excluded</a:t>
+              <a:t>Paper II focus and downstream observations</a:t>
             </a:r>
           </a:p>
         </p:txBody>
@@ -3612,8 +3636,8 @@
         </p:nvSpPr>
         <p:spPr>
           <a:xfrm>
-            <a:off x="274320" y="2148840"/>
-            <a:ext cx="1828800" cy="365760"/>
+            <a:off x="2743200" y="2029968"/>
+            <a:ext cx="6858000" cy="365760"/>
           </a:xfrm>
           <a:prstGeom prst="rect">
             <a:avLst/>
@@ -3627,6 +3651,76 @@
           <a:lstStyle/>
           <a:p>
             <a:pPr>
+              <a:defRPr sz="1100">
+                <a:solidFill>
+                  <a:srgbClr val="0F172A"/>
+                </a:solidFill>
+              </a:defRPr>
+            </a:pPr>
+            <a:r>
+              <a:t>Public resources can drift over time; availability ≠ identity of the input state.</a:t>
+            </a:r>
+          </a:p>
+        </p:txBody>
+      </p:sp>
+      <p:sp>
+        <p:nvSpPr>
+          <p:cNvPr id="15" name="TextBox 14"/>
+          <p:cNvSpPr txBox="1"/>
+          <p:nvPr/>
+        </p:nvSpPr>
+        <p:spPr>
+          <a:xfrm>
+            <a:off x="9784080" y="1664208"/>
+            <a:ext cx="2103120" cy="457200"/>
+          </a:xfrm>
+          <a:prstGeom prst="rect">
+            <a:avLst/>
+          </a:prstGeom>
+          <a:noFill/>
+        </p:spPr>
+        <p:txBody>
+          <a:bodyPr wrap="square" lIns="0" rIns="0">
+            <a:spAutoFit/>
+          </a:bodyPr>
+          <a:lstStyle/>
+          <a:p>
+            <a:pPr>
+              <a:defRPr sz="1400">
+                <a:solidFill>
+                  <a:srgbClr val="0F172A"/>
+                </a:solidFill>
+              </a:defRPr>
+            </a:pPr>
+            <a:r>
+              <a:t>Paper III: excluded</a:t>
+            </a:r>
+          </a:p>
+        </p:txBody>
+      </p:sp>
+      <p:sp>
+        <p:nvSpPr>
+          <p:cNvPr id="16" name="TextBox 15"/>
+          <p:cNvSpPr txBox="1"/>
+          <p:nvPr/>
+        </p:nvSpPr>
+        <p:spPr>
+          <a:xfrm>
+            <a:off x="274320" y="2148840"/>
+            <a:ext cx="1828800" cy="365760"/>
+          </a:xfrm>
+          <a:prstGeom prst="rect">
+            <a:avLst/>
+          </a:prstGeom>
+          <a:noFill/>
+        </p:spPr>
+        <p:txBody>
+          <a:bodyPr wrap="square" lIns="0" rIns="0">
+            <a:spAutoFit/>
+          </a:bodyPr>
+          <a:lstStyle/>
+          <a:p>
+            <a:pPr>
               <a:defRPr sz="1800">
                 <a:solidFill>
                   <a:srgbClr val="0F172A"/>
@@ -3641,7 +3735,7 @@
       </p:sp>
       <p:sp>
         <p:nvSpPr>
-          <p:cNvPr id="15" name="Rounded Rectangle 14"/>
+          <p:cNvPr id="17" name="Rounded Rectangle 16"/>
           <p:cNvSpPr/>
           <p:nvPr/>
         </p:nvSpPr>
@@ -3695,7 +3789,7 @@
       </p:sp>
       <p:sp>
         <p:nvSpPr>
-          <p:cNvPr id="16" name="TextBox 15"/>
+          <p:cNvPr id="18" name="TextBox 17"/>
           <p:cNvSpPr txBox="1"/>
           <p:nvPr/>
         </p:nvSpPr>
@@ -3730,7 +3824,7 @@
       </p:sp>
       <p:sp>
         <p:nvSpPr>
-          <p:cNvPr id="17" name="Rounded Rectangle 16"/>
+          <p:cNvPr id="19" name="Rounded Rectangle 18"/>
           <p:cNvSpPr/>
           <p:nvPr/>
         </p:nvSpPr>
@@ -3784,7 +3878,7 @@
       </p:sp>
       <p:sp>
         <p:nvSpPr>
-          <p:cNvPr id="18" name="TextBox 17"/>
+          <p:cNvPr id="20" name="TextBox 19"/>
           <p:cNvSpPr txBox="1"/>
           <p:nvPr/>
         </p:nvSpPr>
@@ -3819,7 +3913,7 @@
       </p:sp>
       <p:sp>
         <p:nvSpPr>
-          <p:cNvPr id="19" name="Rounded Rectangle 18"/>
+          <p:cNvPr id="21" name="Rounded Rectangle 20"/>
           <p:cNvSpPr/>
           <p:nvPr/>
         </p:nvSpPr>
@@ -3885,7 +3979,7 @@
       </p:sp>
       <p:sp>
         <p:nvSpPr>
-          <p:cNvPr id="20" name="TextBox 19"/>
+          <p:cNvPr id="22" name="TextBox 21"/>
           <p:cNvSpPr txBox="1"/>
           <p:nvPr/>
         </p:nvSpPr>
@@ -3920,7 +4014,7 @@
       </p:sp>
       <p:sp>
         <p:nvSpPr>
-          <p:cNvPr id="21" name="Rounded Rectangle 20"/>
+          <p:cNvPr id="23" name="Rounded Rectangle 22"/>
           <p:cNvSpPr/>
           <p:nvPr/>
         </p:nvSpPr>
@@ -3986,7 +4080,7 @@
       </p:sp>
       <p:sp>
         <p:nvSpPr>
-          <p:cNvPr id="22" name="TextBox 21"/>
+          <p:cNvPr id="24" name="TextBox 23"/>
           <p:cNvSpPr txBox="1"/>
           <p:nvPr/>
         </p:nvSpPr>
@@ -4021,7 +4115,7 @@
       </p:sp>
       <p:sp>
         <p:nvSpPr>
-          <p:cNvPr id="23" name="Rounded Rectangle 22"/>
+          <p:cNvPr id="25" name="Rounded Rectangle 24"/>
           <p:cNvSpPr/>
           <p:nvPr/>
         </p:nvSpPr>
@@ -4075,7 +4169,7 @@
       </p:sp>
       <p:sp>
         <p:nvSpPr>
-          <p:cNvPr id="24" name="TextBox 23"/>
+          <p:cNvPr id="26" name="TextBox 25"/>
           <p:cNvSpPr txBox="1"/>
           <p:nvPr/>
         </p:nvSpPr>
@@ -4110,7 +4204,7 @@
       </p:sp>
       <p:sp>
         <p:nvSpPr>
-          <p:cNvPr id="25" name="Rounded Rectangle 24"/>
+          <p:cNvPr id="27" name="Rounded Rectangle 26"/>
           <p:cNvSpPr/>
           <p:nvPr/>
         </p:nvSpPr>
@@ -4176,7 +4270,7 @@
       </p:sp>
       <p:sp>
         <p:nvSpPr>
-          <p:cNvPr id="26" name="TextBox 25"/>
+          <p:cNvPr id="28" name="TextBox 27"/>
           <p:cNvSpPr txBox="1"/>
           <p:nvPr/>
         </p:nvSpPr>
@@ -4211,7 +4305,7 @@
       </p:sp>
       <p:sp>
         <p:nvSpPr>
-          <p:cNvPr id="27" name="Rounded Rectangle 26"/>
+          <p:cNvPr id="29" name="Rounded Rectangle 28"/>
           <p:cNvSpPr/>
           <p:nvPr/>
         </p:nvSpPr>
@@ -4265,7 +4359,7 @@
       </p:sp>
       <p:sp>
         <p:nvSpPr>
-          <p:cNvPr id="28" name="TextBox 27"/>
+          <p:cNvPr id="30" name="TextBox 29"/>
           <p:cNvSpPr txBox="1"/>
           <p:nvPr/>
         </p:nvSpPr>
@@ -4300,7 +4394,7 @@
       </p:sp>
       <p:sp>
         <p:nvSpPr>
-          <p:cNvPr id="29" name="Rounded Rectangle 28"/>
+          <p:cNvPr id="31" name="Rounded Rectangle 30"/>
           <p:cNvSpPr/>
           <p:nvPr/>
         </p:nvSpPr>
@@ -4354,7 +4448,7 @@
       </p:sp>
       <p:sp>
         <p:nvSpPr>
-          <p:cNvPr id="30" name="TextBox 29"/>
+          <p:cNvPr id="32" name="TextBox 31"/>
           <p:cNvSpPr txBox="1"/>
           <p:nvPr/>
         </p:nvSpPr>
@@ -4389,7 +4483,7 @@
       </p:sp>
       <p:sp>
         <p:nvSpPr>
-          <p:cNvPr id="31" name="Rounded Rectangle 30"/>
+          <p:cNvPr id="33" name="Rounded Rectangle 32"/>
           <p:cNvSpPr/>
           <p:nvPr/>
         </p:nvSpPr>
@@ -4455,7 +4549,7 @@
       </p:sp>
       <p:sp>
         <p:nvSpPr>
-          <p:cNvPr id="32" name="TextBox 31"/>
+          <p:cNvPr id="34" name="TextBox 33"/>
           <p:cNvSpPr txBox="1"/>
           <p:nvPr/>
         </p:nvSpPr>
@@ -4490,7 +4584,7 @@
       </p:sp>
       <p:sp>
         <p:nvSpPr>
-          <p:cNvPr id="33" name="Rounded Rectangle 32"/>
+          <p:cNvPr id="35" name="Rounded Rectangle 34"/>
           <p:cNvSpPr/>
           <p:nvPr/>
         </p:nvSpPr>
@@ -4556,7 +4650,7 @@
       </p:sp>
       <p:sp>
         <p:nvSpPr>
-          <p:cNvPr id="34" name="TextBox 33"/>
+          <p:cNvPr id="36" name="TextBox 35"/>
           <p:cNvSpPr txBox="1"/>
           <p:nvPr/>
         </p:nvSpPr>
@@ -4591,7 +4685,7 @@
       </p:sp>
       <p:sp>
         <p:nvSpPr>
-          <p:cNvPr id="35" name="Rounded Rectangle 34"/>
+          <p:cNvPr id="37" name="Rounded Rectangle 36"/>
           <p:cNvSpPr/>
           <p:nvPr/>
         </p:nvSpPr>
@@ -4645,7 +4739,7 @@
       </p:sp>
       <p:sp>
         <p:nvSpPr>
-          <p:cNvPr id="36" name="TextBox 35"/>
+          <p:cNvPr id="38" name="TextBox 37"/>
           <p:cNvSpPr txBox="1"/>
           <p:nvPr/>
         </p:nvSpPr>
@@ -4680,7 +4774,7 @@
       </p:sp>
       <p:sp>
         <p:nvSpPr>
-          <p:cNvPr id="37" name="Rounded Rectangle 36"/>
+          <p:cNvPr id="39" name="Rounded Rectangle 38"/>
           <p:cNvSpPr/>
           <p:nvPr/>
         </p:nvSpPr>
@@ -4746,7 +4840,7 @@
       </p:sp>
       <p:sp>
         <p:nvSpPr>
-          <p:cNvPr id="38" name="TextBox 37"/>
+          <p:cNvPr id="40" name="TextBox 39"/>
           <p:cNvSpPr txBox="1"/>
           <p:nvPr/>
         </p:nvSpPr>
@@ -4774,7 +4868,7 @@
               </a:defRPr>
             </a:pPr>
             <a:r>
-              <a:t>Figure 1. Conceptual Wet/Dry framework. Paper II focuses on RECONSTRUCT and observes EXECUTE and REPRODUCE. ROBUST belongs to future Paper III and is excluded. The two pathways are an analogy, not a literal equivalence or an empirical result.</a:t>
+              <a:t>Figure 1. Conceptual Wet/Dry framework. ACCESS is refined internally into three questions (resource accessible; exact input state identifiable; historical input state retrievable) because public resources can drift over time. Paper II focuses on RECONSTRUCT and observes EXECUTE and REPRODUCE. ROBUST belongs to future Paper III and is excluded. The two pathways are an analogy, not a literal equivalence or an empirical result.</a:t>
             </a:r>
           </a:p>
         </p:txBody>

</xml_diff>

<commit_message>
Revise Paper II manuscript package to completed-study language; clarify code availability; Section 4/5 framing; extend QC; add REVISION_CHANGELOG
Co-Authored-By: Tatsuki Onishi <bougtoir@gmail.com>
</commit_message>
<xml_diff>
--- a/paper2_reconstruction/manuscript/Figures_editable_EN.pptx
+++ b/paper2_reconstruction/manuscript/Figures_editable_EN.pptx
@@ -3543,7 +3543,7 @@
         <p:spPr>
           <a:xfrm>
             <a:off x="274320" y="1664208"/>
-            <a:ext cx="2194560" cy="822960"/>
+            <a:ext cx="2560320" cy="868680"/>
           </a:xfrm>
           <a:prstGeom prst="rect">
             <a:avLst/>
@@ -3557,7 +3557,7 @@
           <a:lstStyle/>
           <a:p>
             <a:pPr>
-              <a:defRPr sz="900">
+              <a:defRPr sz="1100">
                 <a:solidFill>
                   <a:srgbClr val="0F172A"/>
                 </a:solidFill>
@@ -3569,7 +3569,7 @@
           </a:p>
           <a:p>
             <a:pPr>
-              <a:defRPr sz="900">
+              <a:defRPr sz="1100">
                 <a:solidFill>
                   <a:srgbClr val="0F172A"/>
                 </a:solidFill>
@@ -3581,7 +3581,7 @@
           </a:p>
           <a:p>
             <a:pPr>
-              <a:defRPr sz="900">
+              <a:defRPr sz="1100">
                 <a:solidFill>
                   <a:srgbClr val="0F172A"/>
                 </a:solidFill>
@@ -3601,8 +3601,8 @@
         </p:nvSpPr>
         <p:spPr>
           <a:xfrm>
-            <a:off x="2743200" y="1664208"/>
-            <a:ext cx="6858000" cy="365760"/>
+            <a:off x="2926080" y="1664208"/>
+            <a:ext cx="6675120" cy="365760"/>
           </a:xfrm>
           <a:prstGeom prst="rect">
             <a:avLst/>
@@ -3623,7 +3623,7 @@
               </a:defRPr>
             </a:pPr>
             <a:r>
-              <a:t>Paper II focus and downstream observations</a:t>
+              <a:t>Paper II focus; EXECUTE and REPRODUCE observed</a:t>
             </a:r>
           </a:p>
         </p:txBody>
@@ -3636,8 +3636,8 @@
         </p:nvSpPr>
         <p:spPr>
           <a:xfrm>
-            <a:off x="2743200" y="2029968"/>
-            <a:ext cx="6858000" cy="365760"/>
+            <a:off x="2926080" y="2029968"/>
+            <a:ext cx="6675120" cy="365760"/>
           </a:xfrm>
           <a:prstGeom prst="rect">
             <a:avLst/>
@@ -3671,8 +3671,8 @@
         </p:nvSpPr>
         <p:spPr>
           <a:xfrm>
-            <a:off x="9784080" y="1664208"/>
-            <a:ext cx="2103120" cy="457200"/>
+            <a:off x="9326880" y="1664208"/>
+            <a:ext cx="2743200" cy="457200"/>
           </a:xfrm>
           <a:prstGeom prst="rect">
             <a:avLst/>
@@ -3686,14 +3686,14 @@
           <a:lstStyle/>
           <a:p>
             <a:pPr>
-              <a:defRPr sz="1400">
+              <a:defRPr sz="1300">
                 <a:solidFill>
                   <a:srgbClr val="0F172A"/>
                 </a:solidFill>
               </a:defRPr>
             </a:pPr>
             <a:r>
-              <a:t>Paper III: excluded</a:t>
+              <a:t>ROBUST: future Paper III (excluded)</a:t>
             </a:r>
           </a:p>
         </p:txBody>

</xml_diff>